<commit_message>
32 apresentações PPTX (uma por capítulo)
Co-Authored-By: Claude Sonnet 5.5 <noreply@anthropic.com>
Claude-Session: https://claude.ai/code/session_01LQk7H4UNLk2VXi2CstzPTX
</commit_message>
<xml_diff>
--- a/livro_ia_educacao/saida/pptx/Cap01_slides.pptx
+++ b/livro_ia_educacao/saida/pptx/Cap01_slides.pptx
@@ -9809,11 +9809,11 @@
         <p:spPr>
           <a:xfrm>
             <a:off x="548640" y="1417320"/>
-            <a:ext cx="11064240" cy="762000"/>
+            <a:ext cx="11064240" cy="682752"/>
           </a:xfrm>
           <a:prstGeom prst="roundRect">
             <a:avLst>
-              <a:gd name="adj" fmla="val 14400"/>
+              <a:gd name="adj" fmla="val 16071"/>
             </a:avLst>
           </a:prstGeom>
           <a:solidFill>
@@ -9840,7 +9840,7 @@
         <p:spPr>
           <a:xfrm>
             <a:off x="731520" y="1417320"/>
-            <a:ext cx="548640" cy="762000"/>
+            <a:ext cx="548640" cy="682752"/>
           </a:xfrm>
           <a:prstGeom prst="rect">
             <a:avLst/>
@@ -9876,7 +9876,7 @@
         <p:spPr>
           <a:xfrm>
             <a:off x="1463040" y="1417320"/>
-            <a:ext cx="9966960" cy="762000"/>
+            <a:ext cx="9966960" cy="682752"/>
           </a:xfrm>
           <a:prstGeom prst="rect">
             <a:avLst/>
@@ -9911,12 +9911,12 @@
         </p:nvSpPr>
         <p:spPr>
           <a:xfrm>
-            <a:off x="548640" y="2289048"/>
-            <a:ext cx="11064240" cy="762000"/>
+            <a:off x="548640" y="2209800"/>
+            <a:ext cx="11064240" cy="682752"/>
           </a:xfrm>
           <a:prstGeom prst="roundRect">
             <a:avLst>
-              <a:gd name="adj" fmla="val 14400"/>
+              <a:gd name="adj" fmla="val 16071"/>
             </a:avLst>
           </a:prstGeom>
           <a:solidFill>
@@ -9942,8 +9942,8 @@
         </p:nvSpPr>
         <p:spPr>
           <a:xfrm>
-            <a:off x="731520" y="2289048"/>
-            <a:ext cx="548640" cy="762000"/>
+            <a:off x="731520" y="2209800"/>
+            <a:ext cx="548640" cy="682752"/>
           </a:xfrm>
           <a:prstGeom prst="rect">
             <a:avLst/>
@@ -9978,8 +9978,8 @@
         </p:nvSpPr>
         <p:spPr>
           <a:xfrm>
-            <a:off x="1463040" y="2289048"/>
-            <a:ext cx="9966960" cy="762000"/>
+            <a:off x="1463040" y="2209800"/>
+            <a:ext cx="9966960" cy="682752"/>
           </a:xfrm>
           <a:prstGeom prst="rect">
             <a:avLst/>
@@ -10014,12 +10014,12 @@
         </p:nvSpPr>
         <p:spPr>
           <a:xfrm>
-            <a:off x="548640" y="3160776"/>
-            <a:ext cx="11064240" cy="762000"/>
+            <a:off x="548640" y="3002280"/>
+            <a:ext cx="11064240" cy="682752"/>
           </a:xfrm>
           <a:prstGeom prst="roundRect">
             <a:avLst>
-              <a:gd name="adj" fmla="val 14400"/>
+              <a:gd name="adj" fmla="val 16071"/>
             </a:avLst>
           </a:prstGeom>
           <a:solidFill>
@@ -10045,8 +10045,8 @@
         </p:nvSpPr>
         <p:spPr>
           <a:xfrm>
-            <a:off x="731520" y="3160776"/>
-            <a:ext cx="548640" cy="762000"/>
+            <a:off x="731520" y="3002280"/>
+            <a:ext cx="548640" cy="682752"/>
           </a:xfrm>
           <a:prstGeom prst="rect">
             <a:avLst/>
@@ -10081,8 +10081,8 @@
         </p:nvSpPr>
         <p:spPr>
           <a:xfrm>
-            <a:off x="1463040" y="3160776"/>
-            <a:ext cx="9966960" cy="762000"/>
+            <a:off x="1463040" y="3002280"/>
+            <a:ext cx="9966960" cy="682752"/>
           </a:xfrm>
           <a:prstGeom prst="rect">
             <a:avLst/>
@@ -10117,12 +10117,12 @@
         </p:nvSpPr>
         <p:spPr>
           <a:xfrm>
-            <a:off x="548640" y="4032504"/>
-            <a:ext cx="11064240" cy="762000"/>
+            <a:off x="548640" y="3794760"/>
+            <a:ext cx="11064240" cy="682752"/>
           </a:xfrm>
           <a:prstGeom prst="roundRect">
             <a:avLst>
-              <a:gd name="adj" fmla="val 14400"/>
+              <a:gd name="adj" fmla="val 16071"/>
             </a:avLst>
           </a:prstGeom>
           <a:solidFill>
@@ -10148,8 +10148,8 @@
         </p:nvSpPr>
         <p:spPr>
           <a:xfrm>
-            <a:off x="731520" y="4032504"/>
-            <a:ext cx="548640" cy="762000"/>
+            <a:off x="731520" y="3794760"/>
+            <a:ext cx="548640" cy="682752"/>
           </a:xfrm>
           <a:prstGeom prst="rect">
             <a:avLst/>
@@ -10184,8 +10184,8 @@
         </p:nvSpPr>
         <p:spPr>
           <a:xfrm>
-            <a:off x="1463040" y="4032504"/>
-            <a:ext cx="9966960" cy="762000"/>
+            <a:off x="1463040" y="3794760"/>
+            <a:ext cx="9966960" cy="682752"/>
           </a:xfrm>
           <a:prstGeom prst="rect">
             <a:avLst/>
@@ -10220,12 +10220,12 @@
         </p:nvSpPr>
         <p:spPr>
           <a:xfrm>
-            <a:off x="548640" y="4904232"/>
-            <a:ext cx="11064240" cy="762000"/>
+            <a:off x="548640" y="4587240"/>
+            <a:ext cx="11064240" cy="682752"/>
           </a:xfrm>
           <a:prstGeom prst="roundRect">
             <a:avLst>
-              <a:gd name="adj" fmla="val 14400"/>
+              <a:gd name="adj" fmla="val 16071"/>
             </a:avLst>
           </a:prstGeom>
           <a:solidFill>
@@ -10251,8 +10251,8 @@
         </p:nvSpPr>
         <p:spPr>
           <a:xfrm>
-            <a:off x="731520" y="4904232"/>
-            <a:ext cx="548640" cy="762000"/>
+            <a:off x="731520" y="4587240"/>
+            <a:ext cx="548640" cy="682752"/>
           </a:xfrm>
           <a:prstGeom prst="rect">
             <a:avLst/>
@@ -10287,8 +10287,8 @@
         </p:nvSpPr>
         <p:spPr>
           <a:xfrm>
-            <a:off x="1463040" y="4904232"/>
-            <a:ext cx="9966960" cy="762000"/>
+            <a:off x="1463040" y="4587240"/>
+            <a:ext cx="9966960" cy="682752"/>
           </a:xfrm>
           <a:prstGeom prst="rect">
             <a:avLst/>
@@ -10323,12 +10323,12 @@
         </p:nvSpPr>
         <p:spPr>
           <a:xfrm>
-            <a:off x="548640" y="5775960"/>
-            <a:ext cx="11064240" cy="762000"/>
+            <a:off x="548640" y="5379720"/>
+            <a:ext cx="11064240" cy="682752"/>
           </a:xfrm>
           <a:prstGeom prst="roundRect">
             <a:avLst>
-              <a:gd name="adj" fmla="val 14400"/>
+              <a:gd name="adj" fmla="val 16071"/>
             </a:avLst>
           </a:prstGeom>
           <a:solidFill>
@@ -10354,8 +10354,8 @@
         </p:nvSpPr>
         <p:spPr>
           <a:xfrm>
-            <a:off x="731520" y="5775960"/>
-            <a:ext cx="548640" cy="762000"/>
+            <a:off x="731520" y="5379720"/>
+            <a:ext cx="548640" cy="682752"/>
           </a:xfrm>
           <a:prstGeom prst="rect">
             <a:avLst/>
@@ -10390,8 +10390,8 @@
         </p:nvSpPr>
         <p:spPr>
           <a:xfrm>
-            <a:off x="1463040" y="5775960"/>
-            <a:ext cx="9966960" cy="762000"/>
+            <a:off x="1463040" y="5379720"/>
+            <a:ext cx="9966960" cy="682752"/>
           </a:xfrm>
           <a:prstGeom prst="rect">
             <a:avLst/>

</xml_diff>